<commit_message>
Nettoyage typographique et allègement des commentaires
Uniformisation des tirets et flèches dans le code, les README et le rapport,
docstrings raccourcis, régénération du poster et des slides.
</commit_message>
<xml_diff>
--- a/presentation/presentation_finale.pptx
+++ b/presentation/presentation_finale.pptx
@@ -590,7 +590,7 @@
           <a:lstStyle/>
           <a:p>
             <a:r>
-              <a:t>Question attendue « c'est causal ? » : NON — associations ajustées. L'impact est ex-ante, il sert à PRIORISER. Mesure réelle = pilote + différence de différences (slide 13).</a:t>
+              <a:t>Question attendue « c'est causal ? » : NON - associations ajustées. L'impact est ex-ante, il sert à PRIORISER. Mesure réelle = pilote + différence de différences (slide 13).</a:t>
             </a:r>
           </a:p>
         </p:txBody>
@@ -660,7 +660,7 @@
           <a:lstStyle/>
           <a:p>
             <a:r>
-              <a:t>Hypothèse brouillard : conduite plus prudente — on le dit comme hypothèse, pas comme fait. La valeur différenciante = contredire le common knowledge avec des données.</a:t>
+              <a:t>Hypothèse brouillard : conduite plus prudente - on le dit comme hypothèse, pas comme fait. La valeur différenciante = contredire le common knowledge avec des données.</a:t>
             </a:r>
           </a:p>
         </p:txBody>
@@ -940,7 +940,7 @@
           <a:lstStyle/>
           <a:p>
             <a:r>
-              <a:t>Ce delta brut est TROMPEUR (confondants) — c'est exactement ce que les effets ajustés corrigent. Bon exemple pédagogique si question.</a:t>
+              <a:t>Ce delta brut est TROMPEUR (confondants) - c'est exactement ce que les effets ajustés corrigent. Bon exemple pédagogique si question.</a:t>
             </a:r>
           </a:p>
         </p:txBody>
@@ -1010,7 +1010,7 @@
           <a:lstStyle/>
           <a:p>
             <a:r>
-              <a:t>Au seuil 0,5 : 44 % des graves ratés. Abaisser le seuil ↑ rappel au prix de fausses alertes — arbitrage documenté par la courbe PR.</a:t>
+              <a:t>Au seuil 0,5 : 44 % des graves ratés. Abaisser le seuil ↑ rappel au prix de fausses alertes - arbitrage documenté par la courbe PR.</a:t>
             </a:r>
           </a:p>
         </p:txBody>
@@ -1080,7 +1080,7 @@
           <a:lstStyle/>
           <a:p>
             <a:r>
-              <a:t>SHAP = requête d'attribution (corrélations du réel), g-computation = requête d'intervention. Les signes peuvent différer — documenté dans le notebook.</a:t>
+              <a:t>SHAP = requête d'attribution (corrélations du réel), g-computation = requête d'intervention. Les signes peuvent différer - documenté dans le notebook.</a:t>
             </a:r>
           </a:p>
         </p:txBody>
@@ -1290,7 +1290,7 @@
           <a:lstStyle/>
           <a:p>
             <a:r>
-              <a:t>LA slide méthodo. Question attendue : « pourquoi un prédicteur si vous ne prédisez pas ? » → 1) tâche évaluable, 2) contrôle des confondants, 3) la convergence entre méthodes devient une preuve.</a:t>
+              <a:t>LA slide méthodo. Question attendue : « pourquoi un prédicteur si vous ne prédisez pas ? » -&gt; 1) tâche évaluable, 2) contrôle des confondants, 3) la convergence entre méthodes devient une preuve.</a:t>
             </a:r>
           </a:p>
         </p:txBody>
@@ -1570,7 +1570,7 @@
           <a:lstStyle/>
           <a:p>
             <a:r>
-              <a:t>Performance modeste ASSUMÉE : la gravité dépend de facteurs absents (vitesse réelle, alcool). Notre critère de succès = fiabilité de l'explication, pas la perf brute — c'est mot pour mot dans le sujet. Pourquoi pas SMOTE : class_weight, on ne fabrique pas de données.</a:t>
+              <a:t>Performance modeste ASSUMÉE : la gravité dépend de facteurs absents (vitesse réelle, alcool). Notre critère de succès = fiabilité de l'explication, pas la perf brute - c'est mot pour mot dans le sujet. Pourquoi pas SMOTE : class_weight, on ne fabrique pas de données.</a:t>
             </a:r>
           </a:p>
         </p:txBody>
@@ -1640,7 +1640,7 @@
           <a:lstStyle/>
           <a:p>
             <a:r>
-              <a:t>Point clé : une moyenne brute « avec/sans feux » dirait l'INVERSE (les feux sont là où c'est dense). Les effets ajustés renversent la lecture — c'est LA démonstration de l'utilité du modèle. SHAP en annexe : requête d'intervention (g-comp) ≠ requête d'attribution (SHAP).</a:t>
+              <a:t>Point clé : une moyenne brute « avec/sans feux » dirait l'INVERSE (les feux sont là où c'est dense). Les effets ajustés renversent la lecture - c'est LA démonstration de l'utilité du modèle. SHAP en annexe : requête d'intervention (g-comp) ≠ requête d'attribution (SHAP).</a:t>
             </a:r>
           </a:p>
         </p:txBody>
@@ -4750,7 +4750,7 @@
                 </a:solidFill>
                 <a:latin typeface="Calibri"/>
               </a:rPr>
-              <a:t>Données US Accidents — 7,73 M accidents · 2016-2023 · 49 États</a:t>
+              <a:t>Données US Accidents - 7,73 M accidents , 2016-2023 , 49 États</a:t>
             </a:r>
           </a:p>
           <a:p>
@@ -4762,7 +4762,7 @@
                 <a:latin typeface="Calibri"/>
               </a:rPr>
               <a:t>
-SAÉ DataValueXploring — juillet 2026</a:t>
+SAÉ DataValueXploring - juillet 2026</a:t>
             </a:r>
           </a:p>
         </p:txBody>
@@ -4820,7 +4820,7 @@
                 </a:solidFill>
                 <a:latin typeface="Calibri"/>
               </a:rPr>
-              <a:t>50 zones prioritaires — Californie (démo)</a:t>
+              <a:t>50 zones prioritaires - Californie (démo)</a:t>
             </a:r>
           </a:p>
         </p:txBody>
@@ -5142,7 +5142,7 @@
                 </a:solidFill>
                 <a:latin typeface="Calibri"/>
               </a:rPr>
-              <a:t>QUOI — de l'explication à la prescription</a:t>
+              <a:t>QUOI - de l'explication à la prescription</a:t>
             </a:r>
           </a:p>
         </p:txBody>
@@ -5240,7 +5240,7 @@
                 </a:solidFill>
                 <a:latin typeface="Consolas"/>
               </a:rPr>
-              <a:t>   → recommandation + impact estimé = |Δ_adj| × volume  =  accidents GRAVES évités</a:t>
+              <a:t>   -&gt; recommandation + impact estimé = |Δ_adj| × volume  =  accidents GRAVES évités</a:t>
             </a:r>
           </a:p>
         </p:txBody>
@@ -5297,7 +5297,7 @@
                 </a:solidFill>
                 <a:latin typeface="Calibri"/>
               </a:rPr>
-              <a:t> (2 543 accidents, aléa carrefour) → « stop / cédez-le-passage », </a:t>
+              <a:t> (2 543 accidents, aléa carrefour) -&gt; « stop / cédez-le-passage », </a:t>
             </a:r>
             <a:r>
               <a:rPr sz="1500" b="1">
@@ -5349,7 +5349,7 @@
                 </a:solidFill>
                 <a:latin typeface="Calibri"/>
               </a:rPr>
-              <a:t> de recommandations sur les 50 zones — l'effet conditionnel évite le « même aménagement partout »</a:t>
+              <a:t> de recommandations sur les 50 zones - l'effet conditionnel évite le « même aménagement partout »</a:t>
             </a:r>
           </a:p>
           <a:p>
@@ -5365,7 +5365,7 @@
                 </a:solidFill>
                 <a:latin typeface="Calibri"/>
               </a:rPr>
-              <a:t>• 13 zones sans levier infra dominant → « </a:t>
+              <a:t>• 13 zones sans levier infra dominant -&gt; « </a:t>
             </a:r>
             <a:r>
               <a:rPr sz="1500" b="1">
@@ -5399,7 +5399,7 @@
                 </a:solidFill>
                 <a:latin typeface="Calibri"/>
               </a:rPr>
-              <a:t>• Contre-vérification systématique : effet ajusté (modèle) ↔ effet brut (données)</a:t>
+              <a:t>• Contre-vérification systématique : effet ajusté (modèle) &lt;-&gt; effet brut (données)</a:t>
             </a:r>
           </a:p>
         </p:txBody>
@@ -5469,7 +5469,7 @@
                 </a:solidFill>
                 <a:latin typeface="Calibri"/>
               </a:rPr>
-              <a:t>QUAND — les contre-intuitifs qui font gagner du budget</a:t>
+              <a:t>QUAND - les contre-intuitifs qui font gagner du budget</a:t>
             </a:r>
           </a:p>
           <a:p>
@@ -5653,7 +5653,7 @@
                 </a:solidFill>
                 <a:latin typeface="Calibri"/>
               </a:rPr>
-              <a:t>• → météo &amp; calendrier = </a:t>
+              <a:t>• -&gt; météo &amp; calendrier = </a:t>
             </a:r>
             <a:r>
               <a:rPr sz="1400" b="1">
@@ -5741,7 +5741,7 @@
                 </a:solidFill>
                 <a:latin typeface="Calibri"/>
               </a:rPr>
-              <a:t>Le livrable décisionnel — ce que le DOT ouvre lundi matin</a:t>
+              <a:t>Le livrable décisionnel - ce que le DOT ouvre lundi matin</a:t>
             </a:r>
           </a:p>
         </p:txBody>
@@ -6383,7 +6383,7 @@
                 </a:solidFill>
                 <a:latin typeface="Calibri"/>
               </a:rPr>
-              <a:t>– *ex-ante, associationnel — à valider par visite terrain puis pilote</a:t>
+              <a:t>– *ex-ante, associationnel - à valider par visite terrain puis pilote</a:t>
             </a:r>
           </a:p>
         </p:txBody>
@@ -6453,7 +6453,7 @@
                 </a:solidFill>
                 <a:latin typeface="Calibri"/>
               </a:rPr>
-              <a:t>Limites &amp; recul — ce qu'on ne prétend pas</a:t>
+              <a:t>Limites &amp; recul - ce qu'on ne prétend pas</a:t>
             </a:r>
           </a:p>
         </p:txBody>
@@ -6510,7 +6510,7 @@
                 </a:solidFill>
                 <a:latin typeface="Calibri"/>
               </a:rPr>
-              <a:t> : aucune donnée avant/après installation → signaux de priorisation, pas preuves d'efficacité</a:t>
+              <a:t> : aucune donnée avant/après installation -&gt; signaux de priorisation, pas preuves d'efficacité</a:t>
             </a:r>
           </a:p>
           <a:p>
@@ -6544,7 +6544,7 @@
                 </a:solidFill>
                 <a:latin typeface="Calibri"/>
               </a:rPr>
-              <a:t> : couverture inégale — fiable sur les territoires à fort volume seulement</a:t>
+              <a:t> : couverture inégale - fiable sur les territoires à fort volume seulement</a:t>
             </a:r>
           </a:p>
           <a:p>
@@ -6560,7 +6560,7 @@
                 </a:solidFill>
                 <a:latin typeface="Calibri"/>
               </a:rPr>
-              <a:t>• Pas de profil conducteur (vitesse, alcool) · `severity` = seul proxy du coût</a:t>
+              <a:t>• Pas de profil conducteur (vitesse, alcool) , `severity` = seul proxy du coût</a:t>
             </a:r>
           </a:p>
           <a:p>
@@ -6594,7 +6594,7 @@
                 </a:solidFill>
                 <a:latin typeface="Calibri"/>
               </a:rPr>
-              <a:t> (42/50) : API Overpass limitée — cache livré, dégradation propre</a:t>
+              <a:t> (42/50) : API Overpass limitée - cache livré, dégradation propre</a:t>
             </a:r>
           </a:p>
         </p:txBody>
@@ -6675,7 +6675,7 @@
                 </a:solidFill>
                 <a:latin typeface="Calibri"/>
               </a:rPr>
-              <a:t> (zones traitées vs témoins, avant/après) — KPI : coût par accident grave évité.</a:t>
+              <a:t> (zones traitées vs témoins, avant/après) - KPI : coût par accident grave évité.</a:t>
             </a:r>
           </a:p>
         </p:txBody>
@@ -6745,7 +6745,7 @@
                 </a:solidFill>
                 <a:latin typeface="Calibri"/>
               </a:rPr>
-              <a:t>Conclusion — la valeur créée</a:t>
+              <a:t>Conclusion - la valeur créée</a:t>
             </a:r>
           </a:p>
         </p:txBody>
@@ -6854,7 +6854,7 @@
                 </a:solidFill>
                 <a:latin typeface="Calibri"/>
               </a:rPr>
-              <a:t> : 50 zones validées — concentration ×62, stabilité ρ = 0,78, exposition contrôlée</a:t>
+              <a:t> : 50 zones validées - concentration ×62, stabilité ρ = 0,78, exposition contrôlée</a:t>
             </a:r>
           </a:p>
           <a:p>
@@ -6922,7 +6922,7 @@
                 </a:solidFill>
                 <a:latin typeface="Calibri"/>
               </a:rPr>
-              <a:t> : mesures dynamiques vs travaux — bien séparés, budget préservé</a:t>
+              <a:t> : mesures dynamiques vs travaux - bien séparés, budget préservé</a:t>
             </a:r>
           </a:p>
           <a:p>
@@ -7124,7 +7124,7 @@
                 </a:solidFill>
                 <a:latin typeface="Calibri"/>
               </a:rPr>
-              <a:t>Annexes — Q&amp;A</a:t>
+              <a:t>Annexes - Q&amp;A</a:t>
             </a:r>
           </a:p>
         </p:txBody>
@@ -7194,7 +7194,7 @@
                 </a:solidFill>
                 <a:latin typeface="Calibri"/>
               </a:rPr>
-              <a:t>Annexe A — Nettoyage &amp; prétraitement (explicite, justifié)</a:t>
+              <a:t>Annexe A - Nettoyage &amp; prétraitement (explicite, justifié)</a:t>
             </a:r>
           </a:p>
         </p:txBody>
@@ -7257,7 +7257,7 @@
                 </a:solidFill>
                 <a:latin typeface="Calibri"/>
               </a:rPr>
-              <a:t>• `end_lat/lng` (44 % NA) → </a:t>
+              <a:t>• `end_lat/lng` (44 % NA) -&gt; </a:t>
             </a:r>
             <a:r>
               <a:rPr sz="1350" b="1">
@@ -7275,7 +7275,7 @@
                 </a:solidFill>
                 <a:latin typeface="Calibri"/>
               </a:rPr>
-              <a:t> ; `wind_chill` → supprimée (redondante)</a:t>
+              <a:t> ; `wind_chill` -&gt; supprimée (redondante)</a:t>
             </a:r>
           </a:p>
           <a:p>
@@ -7291,7 +7291,7 @@
                 </a:solidFill>
                 <a:latin typeface="Calibri"/>
               </a:rPr>
-              <a:t>• Météo : imputation médiane · texte libre regroupé en 6 familles</a:t>
+              <a:t>• Météo : imputation médiane , texte libre regroupé en 6 familles</a:t>
             </a:r>
           </a:p>
           <a:p>
@@ -7307,7 +7307,7 @@
                 </a:solidFill>
                 <a:latin typeface="Calibri"/>
               </a:rPr>
-              <a:t>• Booléens d'infra NA → </a:t>
+              <a:t>• Booléens d'infra NA -&gt; </a:t>
             </a:r>
             <a:r>
               <a:rPr sz="1350" b="1">
@@ -7325,7 +7325,7 @@
                 </a:solidFill>
                 <a:latin typeface="Calibri"/>
               </a:rPr>
-              <a:t> · sévérité binarisée (classe 2 = 80 %)</a:t>
+              <a:t> , sévérité binarisée (classe 2 = 80 %)</a:t>
             </a:r>
           </a:p>
           <a:p>
@@ -7429,7 +7429,7 @@
                 </a:solidFill>
                 <a:latin typeface="Calibri"/>
               </a:rPr>
-              <a:t>Annexe B — Le signal descriptif brut (avant modèle)</a:t>
+              <a:t>Annexe B - Le signal descriptif brut (avant modèle)</a:t>
             </a:r>
           </a:p>
         </p:txBody>
@@ -7542,7 +7542,7 @@
                 </a:solidFill>
                 <a:latin typeface="Calibri"/>
               </a:rPr>
-              <a:t>• → c'est pourquoi la preuve finale utilise les </a:t>
+              <a:t>• -&gt; c'est pourquoi la preuve finale utilise les </a:t>
             </a:r>
             <a:r>
               <a:rPr sz="1350" b="1">
@@ -7621,7 +7621,7 @@
                 </a:solidFill>
                 <a:latin typeface="Calibri"/>
               </a:rPr>
-              <a:t>Annexe C — Analyse des erreurs du modèle</a:t>
+              <a:t>Annexe C - Analyse des erreurs du modèle</a:t>
             </a:r>
           </a:p>
         </p:txBody>
@@ -7718,7 +7718,7 @@
                 </a:solidFill>
                 <a:latin typeface="Calibri"/>
               </a:rPr>
-              <a:t>• Courbes PR vs plancher : l'arbitrage seuil ↔ fausses alertes est explicite</a:t>
+              <a:t>• Courbes PR vs plancher : l'arbitrage seuil &lt;-&gt; fausses alertes est explicite</a:t>
             </a:r>
           </a:p>
         </p:txBody>
@@ -7788,7 +7788,7 @@
                 </a:solidFill>
                 <a:latin typeface="Calibri"/>
               </a:rPr>
-              <a:t>Annexe D — Robustesse : SHAP &amp; convergence entre approches</a:t>
+              <a:t>Annexe D - Robustesse : SHAP &amp; convergence entre approches</a:t>
             </a:r>
           </a:p>
         </p:txBody>
@@ -7909,7 +7909,7 @@
                 </a:solidFill>
                 <a:latin typeface="Calibri"/>
               </a:rPr>
-              <a:t>• Entrées : 12 booléens d'infra (leviers) + contrôles météo/temps/géo — </a:t>
+              <a:t>• Entrées : 12 booléens d'infra (leviers) + contrôles météo/temps/géo - </a:t>
             </a:r>
             <a:r>
               <a:rPr sz="1250" b="1">
@@ -8108,7 +8108,7 @@
                 </a:solidFill>
                 <a:latin typeface="Calibri"/>
               </a:rPr>
-              <a:t> — remontées terrain, accidents médiatisés, arbitrages politiques</a:t>
+              <a:t> - remontées terrain, accidents médiatisés, arbitrages politiques</a:t>
             </a:r>
           </a:p>
           <a:p>
@@ -8316,7 +8316,7 @@
                 </a:solidFill>
                 <a:latin typeface="Calibri"/>
               </a:rPr>
-              <a:t>Les données — et leurs pièges</a:t>
+              <a:t>Les données - et leurs pièges</a:t>
             </a:r>
           </a:p>
           <a:p>
@@ -8327,7 +8327,7 @@
                 </a:solidFill>
                 <a:latin typeface="Calibri"/>
               </a:rPr>
-              <a:t>US Accidents (Kaggle) · Feb 2016 → Mar 2023</a:t>
+              <a:t>US Accidents (Kaggle) , Feb 2016 -&gt; Mar 2023</a:t>
             </a:r>
           </a:p>
         </p:txBody>
@@ -8400,7 +8400,7 @@
                 </a:solidFill>
                 <a:latin typeface="Calibri"/>
               </a:rPr>
-              <a:t>• Collecte via API trafic → </a:t>
+              <a:t>• Collecte via API trafic -&gt; </a:t>
             </a:r>
             <a:r>
               <a:rPr sz="1500" b="1">
@@ -8486,7 +8486,7 @@
                 </a:solidFill>
                 <a:latin typeface="Calibri"/>
               </a:rPr>
-              <a:t> les États entre eux —</a:t>
+              <a:t> les États entre eux -</a:t>
             </a:r>
           </a:p>
           <a:p>
@@ -8641,7 +8641,7 @@
                 </a:solidFill>
                 <a:latin typeface="Calibri"/>
               </a:rPr>
-              <a:t>Pas de modèle « par habitude » — la méthode suit la nature de la question</a:t>
+              <a:t>Pas de modèle « par habitude » - la méthode suit la nature de la question</a:t>
             </a:r>
           </a:p>
         </p:txBody>
@@ -8772,7 +8772,7 @@
                           </a:solidFill>
                           <a:latin typeface="Calibri"/>
                         </a:rPr>
-                        <a:t>concentration → descriptif</a:t>
+                        <a:t>concentration -&gt; descriptif</a:t>
                       </a:r>
                     </a:p>
                   </a:txBody>
@@ -8840,7 +8840,7 @@
                           </a:solidFill>
                           <a:latin typeface="Calibri"/>
                         </a:rPr>
-                        <a:t>attribution → ML (moteur de preuve)</a:t>
+                        <a:t>attribution -&gt; ML (moteur de preuve)</a:t>
                       </a:r>
                     </a:p>
                   </a:txBody>
@@ -8862,7 +8862,7 @@
                           </a:solidFill>
                           <a:latin typeface="Calibri"/>
                         </a:rPr>
-                        <a:t>modèle de gravité → effets ajustés</a:t>
+                        <a:t>modèle de gravité -&gt; effets ajustés</a:t>
                       </a:r>
                     </a:p>
                   </a:txBody>
@@ -8908,7 +8908,7 @@
                           </a:solidFill>
                           <a:latin typeface="Calibri"/>
                         </a:rPr>
-                        <a:t>conjoncturel → descriptif</a:t>
+                        <a:t>conjoncturel -&gt; descriptif</a:t>
                       </a:r>
                     </a:p>
                   </a:txBody>
@@ -9003,7 +9003,7 @@
                 </a:solidFill>
                 <a:latin typeface="Calibri"/>
               </a:rPr>
-              <a:t> On entraîne un modèle de gravité pour l'interroger — quels équipements aggravent, à contexte égal — pas pour prédire.</a:t>
+              <a:t> On entraîne un modèle de gravité pour l'interroger - quels équipements aggravent, à contexte égal - pas pour prédire.</a:t>
             </a:r>
           </a:p>
         </p:txBody>
@@ -9060,7 +9060,7 @@
                 </a:solidFill>
                 <a:latin typeface="Calibri"/>
               </a:rPr>
-              <a:t> est une question de concentration → agrégation, pas de ML supervisé (assumé)</a:t>
+              <a:t> est une question de concentration -&gt; agrégation, pas de ML supervisé (assumé)</a:t>
             </a:r>
           </a:p>
           <a:p>
@@ -9094,7 +9094,7 @@
                 </a:solidFill>
                 <a:latin typeface="Calibri"/>
               </a:rPr>
-              <a:t> est une question d'attribution → c'est là que le ML apporte de la valeur</a:t>
+              <a:t> est une question d'attribution -&gt; c'est là que le ML apporte de la valeur</a:t>
             </a:r>
           </a:p>
           <a:p>
@@ -9128,7 +9128,7 @@
                 </a:solidFill>
                 <a:latin typeface="Calibri"/>
               </a:rPr>
-              <a:t> est conjoncturel → visualisé, pas modélisé (pour ne pas diluer le fil rouge)</a:t>
+              <a:t> est conjoncturel -&gt; visualisé, pas modélisé (pour ne pas diluer le fil rouge)</a:t>
             </a:r>
           </a:p>
         </p:txBody>
@@ -9263,7 +9263,7 @@
                 </a:solidFill>
                 <a:latin typeface="Consolas"/>
               </a:rPr>
-              <a:t>Setup reproductible  →  Chargement Spark (schéma explicite)  →  Nettoyage explicite &amp; testé</a:t>
+              <a:t>Setup reproductible  -&gt;  Chargement Spark (schéma explicite)  -&gt;  Nettoyage explicite &amp; testé</a:t>
             </a:r>
           </a:p>
           <a:p>
@@ -9285,7 +9285,7 @@
                 </a:solidFill>
                 <a:latin typeface="Consolas"/>
               </a:rPr>
-              <a:t>   ├─  B. OÙ  : grille H3 → charge pondérée gravité → exposition OSM (acc/km) + stabilité</a:t>
+              <a:t>   ├─  B. OÙ  : grille H3 -&gt; charge pondérée gravité -&gt; exposition OSM (acc/km) + stabilité</a:t>
             </a:r>
           </a:p>
           <a:p>
@@ -9296,7 +9296,7 @@
                 </a:solidFill>
                 <a:latin typeface="Consolas"/>
               </a:rPr>
-              <a:t>   ├─  C. QUOI: 5 modèles comparés → effets ajustés (odds ratios + g-computation) → leviers</a:t>
+              <a:t>   ├─  C. QUOI: 5 modèles comparés -&gt; effets ajustés (odds ratios + g-computation) -&gt; leviers</a:t>
             </a:r>
           </a:p>
           <a:p>
@@ -9375,7 +9375,7 @@
                 </a:solidFill>
                 <a:latin typeface="Calibri"/>
               </a:rPr>
-              <a:t> pour les 7,73 M lignes (chargement, nettoyage, agrégations, split) — pandas saturerait</a:t>
+              <a:t> pour les 7,73 M lignes (chargement, nettoyage, agrégations, split) - pandas saturerait</a:t>
             </a:r>
           </a:p>
           <a:p>
@@ -9513,7 +9513,7 @@
                 </a:solidFill>
                 <a:latin typeface="Calibri"/>
               </a:rPr>
-              <a:t>OÙ — le risque est très concentré</a:t>
+              <a:t>OÙ - le risque est très concentré</a:t>
             </a:r>
           </a:p>
           <a:p>
@@ -9524,7 +9524,7 @@
                 </a:solidFill>
                 <a:latin typeface="Calibri"/>
               </a:rPr>
-              <a:t>Californie (démonstration) : 1,74 M accidents → 58 857 zones H3 de ~0,7 km²</a:t>
+              <a:t>Californie (démonstration) : 1,74 M accidents -&gt; 58 857 zones H3 de ~0,7 km²</a:t>
             </a:r>
           </a:p>
         </p:txBody>
@@ -9797,7 +9797,7 @@
                 </a:solidFill>
                 <a:latin typeface="Calibri"/>
               </a:rPr>
-              <a:t>OÙ — deux validations qui rendent le classement défendable</a:t>
+              <a:t>OÙ - deux validations qui rendent le classement défendable</a:t>
             </a:r>
           </a:p>
         </p:txBody>
@@ -9912,7 +9912,7 @@
                 </a:solidFill>
                 <a:latin typeface="Calibri"/>
               </a:rPr>
-              <a:t> — les points noirs sont-ils du bruit ?</a:t>
+              <a:t> - les points noirs sont-ils du bruit ?</a:t>
             </a:r>
           </a:p>
           <a:p>
@@ -9980,7 +9980,7 @@
                 </a:solidFill>
                 <a:latin typeface="Calibri"/>
               </a:rPr>
-              <a:t> → risque structurel</a:t>
+              <a:t> -&gt; risque structurel</a:t>
             </a:r>
           </a:p>
           <a:p>
@@ -10014,7 +10014,7 @@
                 </a:solidFill>
                 <a:latin typeface="Calibri"/>
               </a:rPr>
-              <a:t> — dangereux, ou juste fréquenté ?</a:t>
+              <a:t> - dangereux, ou juste fréquenté ?</a:t>
             </a:r>
           </a:p>
           <a:p>
@@ -10030,7 +10030,7 @@
                 </a:solidFill>
                 <a:latin typeface="Calibri"/>
               </a:rPr>
-              <a:t>– longueur de voirie par zone → </a:t>
+              <a:t>– longueur de voirie par zone -&gt; </a:t>
             </a:r>
             <a:r>
               <a:rPr sz="1300" b="1">
@@ -10048,7 +10048,7 @@
                 </a:solidFill>
                 <a:latin typeface="Calibri"/>
               </a:rPr>
-              <a:t> → re-classement</a:t>
+              <a:t> -&gt; re-classement</a:t>
             </a:r>
           </a:p>
           <a:p>
@@ -10098,7 +10098,7 @@
                 </a:solidFill>
                 <a:latin typeface="Calibri"/>
               </a:rPr>
-              <a:t>– couverture : 42/50 zones (API Overpass limitée — cache local livré, dégradation documentée)</a:t>
+              <a:t>– couverture : 42/50 zones (API Overpass limitée - cache local livré, dégradation documentée)</a:t>
             </a:r>
           </a:p>
         </p:txBody>
@@ -10168,7 +10168,7 @@
                 </a:solidFill>
                 <a:latin typeface="Calibri"/>
               </a:rPr>
-              <a:t>QUOI — une comparaison honnête de 5 modèles</a:t>
+              <a:t>QUOI - une comparaison honnête de 5 modèles</a:t>
             </a:r>
           </a:p>
           <a:p>
@@ -10179,7 +10179,7 @@
                 </a:solidFill>
                 <a:latin typeface="Calibri"/>
               </a:rPr>
-              <a:t>Split temporel : train &lt; 2022, test 2022-2023 — on prédit l'avenir avec le passé</a:t>
+              <a:t>Split temporel : train &lt; 2022, test 2022-2023 - on prédit l'avenir avec le passé</a:t>
             </a:r>
           </a:p>
         </p:txBody>
@@ -10960,7 +10960,7 @@
                 </a:solidFill>
                 <a:latin typeface="Calibri"/>
               </a:rPr>
-              <a:t> — c'est tout ce qu'on lui demande : il sert de moteur de preuve, pas d'oracle.</a:t>
+              <a:t> - c'est tout ce qu'on lui demande : il sert de moteur de preuve, pas d'oracle.</a:t>
             </a:r>
           </a:p>
         </p:txBody>
@@ -11030,7 +11030,7 @@
                 </a:solidFill>
                 <a:latin typeface="Calibri"/>
               </a:rPr>
-              <a:t>QUOI — les effets ajustés : la réponse claire</a:t>
+              <a:t>QUOI - les effets ajustés : la réponse claire</a:t>
             </a:r>
           </a:p>
           <a:p>
@@ -11164,7 +11164,7 @@
                 </a:solidFill>
                 <a:latin typeface="Calibri"/>
               </a:rPr>
-              <a:t> · stop </a:t>
+              <a:t> , stop </a:t>
             </a:r>
             <a:r>
               <a:rPr sz="1400" b="1">
@@ -11182,7 +11182,7 @@
                 </a:solidFill>
                 <a:latin typeface="Calibri"/>
               </a:rPr>
-              <a:t> · feux </a:t>
+              <a:t> , feux </a:t>
             </a:r>
             <a:r>
               <a:rPr sz="1400" b="1">
@@ -11200,7 +11200,7 @@
                 </a:solidFill>
                 <a:latin typeface="Calibri"/>
               </a:rPr>
-              <a:t> → protecteurs ; carrefour 1,2 · voie ferrée 1,7 → aggravants</a:t>
+              <a:t> -&gt; protecteurs ; carrefour 1,2 , voie ferrée 1,7 -&gt; aggravants</a:t>
             </a:r>
           </a:p>
           <a:p>
@@ -11234,7 +11234,7 @@
                 </a:solidFill>
                 <a:latin typeface="Calibri"/>
               </a:rPr>
-              <a:t> (modèle retenu) : on « allume/éteint » l'équipement à contexte constant → passage piéton </a:t>
+              <a:t> (modèle retenu) : on « allume/éteint » l'équipement à contexte constant -&gt; passage piéton </a:t>
             </a:r>
             <a:r>
               <a:rPr sz="1400" b="1">
@@ -11304,7 +11304,7 @@
                 </a:solidFill>
                 <a:latin typeface="Calibri"/>
               </a:rPr>
-              <a:t> → diagnostic robuste</a:t>
+              <a:t> -&gt; diagnostic robuste</a:t>
             </a:r>
           </a:p>
         </p:txBody>

</xml_diff>